<commit_message>
docs: reconcile submission evidence and stale project information
Repair published export digests with original values retained; scope review
labels and preserve export-time status. Label the superseded demo script,
correct unshipped-control disclosures in slides and deck, refresh builder
notes, and remove the stale corpus test count. Add 13 regression checks.

Reviewed independently on GLM-5.3. Final browser suite: 1871 run, zero
failures/errors, two archived-baseline opt-in skips. No application, UI,
data, policy, launcher or deployment changes. No EdgeOne redeploy.
</commit_message>
<xml_diff>
--- a/tools/deployment/ryde-dispute-pitch.pptx
+++ b/tools/deployment/ryde-dispute-pitch.pptx
@@ -4177,7 +4177,7 @@
                 <a:ea typeface="Calibri" pitchFamily="34" charset="-122"/>
                 <a:cs typeface="Calibri" pitchFamily="34" charset="-120"/>
               </a:rPr>
-              <a:t>CONTROLS FROM DAY ONE</a:t>
+              <a:t>BUILT TODAY / BEFORE GO-LIVE</a:t>
             </a:r>
             <a:endParaRPr lang="en-US" sz="1100" dirty="0"/>
           </a:p>
@@ -4241,7 +4241,7 @@
                 <a:ea typeface="Calibri" pitchFamily="34" charset="-122"/>
                 <a:cs typeface="Calibri" pitchFamily="34" charset="-120"/>
               </a:rPr>
-              <a:t>Kill switch that withholds every ruling</a:t>
+              <a:t>Before go-live: add a kill switch to pause rulings</a:t>
             </a:r>
             <a:endParaRPr lang="en-US" sz="1300" dirty="0"/>
           </a:p>
@@ -4262,7 +4262,7 @@
                 <a:ea typeface="Calibri" pitchFamily="34" charset="-122"/>
                 <a:cs typeface="Calibri" pitchFamily="34" charset="-120"/>
               </a:rPr>
-              <a:t>PII redaction before any model call</a:t>
+              <a:t>Before go-live: remove personal data before AI</a:t>
             </a:r>
             <a:endParaRPr lang="en-US" sz="1300" dirty="0"/>
           </a:p>

</xml_diff>

<commit_message>
docs: align model roles, evaluation and cost scenarios
</commit_message>
<xml_diff>
--- a/tools/deployment/ryde-dispute-pitch.pptx
+++ b/tools/deployment/ryde-dispute-pitch.pptx
@@ -670,112 +670,112 @@
                   <c:v>0</c:v>
                 </c:pt>
                 <c:pt idx="1">
-                  <c:v>40</c:v>
+                  <c:v>40.0</c:v>
                 </c:pt>
                 <c:pt idx="2">
-                  <c:v>80</c:v>
+                  <c:v>80.0</c:v>
                 </c:pt>
                 <c:pt idx="3">
-                  <c:v>120</c:v>
+                  <c:v>120.0</c:v>
                 </c:pt>
                 <c:pt idx="4">
-                  <c:v>160</c:v>
+                  <c:v>160.0</c:v>
                 </c:pt>
                 <c:pt idx="5">
-                  <c:v>170</c:v>
+                  <c:v>170.2</c:v>
                 </c:pt>
                 <c:pt idx="6">
-                  <c:v>180</c:v>
+                  <c:v>180.3</c:v>
                 </c:pt>
                 <c:pt idx="7">
-                  <c:v>184.2</c:v>
+                  <c:v>184.7</c:v>
                 </c:pt>
                 <c:pt idx="8">
-                  <c:v>188.4</c:v>
+                  <c:v>189.0</c:v>
                 </c:pt>
                 <c:pt idx="9">
-                  <c:v>192.6</c:v>
+                  <c:v>193.4</c:v>
                 </c:pt>
                 <c:pt idx="10">
-                  <c:v>194.2</c:v>
+                  <c:v>195.2</c:v>
                 </c:pt>
                 <c:pt idx="11">
-                  <c:v>195.9</c:v>
+                  <c:v>197.1</c:v>
                 </c:pt>
                 <c:pt idx="12">
-                  <c:v>197.6</c:v>
+                  <c:v>198.9</c:v>
                 </c:pt>
                 <c:pt idx="13">
-                  <c:v>199.5</c:v>
+                  <c:v>200.9</c:v>
                 </c:pt>
                 <c:pt idx="14">
-                  <c:v>201.3</c:v>
+                  <c:v>203.0</c:v>
                 </c:pt>
                 <c:pt idx="15">
-                  <c:v>203.2</c:v>
+                  <c:v>205.0</c:v>
                 </c:pt>
                 <c:pt idx="16">
-                  <c:v>205</c:v>
+                  <c:v>207.0</c:v>
                 </c:pt>
                 <c:pt idx="17">
-                  <c:v>206.9</c:v>
+                  <c:v>209.0</c:v>
                 </c:pt>
                 <c:pt idx="18">
-                  <c:v>208.7</c:v>
+                  <c:v>211.1</c:v>
                 </c:pt>
                 <c:pt idx="19">
-                  <c:v>210.5</c:v>
+                  <c:v>213.1</c:v>
                 </c:pt>
                 <c:pt idx="20">
-                  <c:v>212.4</c:v>
+                  <c:v>215.1</c:v>
                 </c:pt>
                 <c:pt idx="21">
-                  <c:v>214.2</c:v>
+                  <c:v>217.1</c:v>
                 </c:pt>
                 <c:pt idx="22">
-                  <c:v>216.1</c:v>
+                  <c:v>219.2</c:v>
                 </c:pt>
                 <c:pt idx="23">
-                  <c:v>217.9</c:v>
+                  <c:v>221.2</c:v>
                 </c:pt>
                 <c:pt idx="24">
-                  <c:v>219.8</c:v>
+                  <c:v>223.2</c:v>
                 </c:pt>
                 <c:pt idx="25">
-                  <c:v>221.8</c:v>
+                  <c:v>225.4</c:v>
                 </c:pt>
                 <c:pt idx="26">
-                  <c:v>223.9</c:v>
+                  <c:v>227.7</c:v>
                 </c:pt>
                 <c:pt idx="27">
-                  <c:v>225.9</c:v>
+                  <c:v>229.9</c:v>
                 </c:pt>
                 <c:pt idx="28">
-                  <c:v>227.9</c:v>
+                  <c:v>232.1</c:v>
                 </c:pt>
                 <c:pt idx="29">
-                  <c:v>230</c:v>
+                  <c:v>234.4</c:v>
                 </c:pt>
                 <c:pt idx="30">
-                  <c:v>232</c:v>
+                  <c:v>236.6</c:v>
                 </c:pt>
                 <c:pt idx="31">
-                  <c:v>234</c:v>
+                  <c:v>238.8</c:v>
                 </c:pt>
                 <c:pt idx="32">
-                  <c:v>236.1</c:v>
+                  <c:v>241.0</c:v>
                 </c:pt>
                 <c:pt idx="33">
-                  <c:v>238.1</c:v>
+                  <c:v>243.3</c:v>
                 </c:pt>
                 <c:pt idx="34">
-                  <c:v>240.1</c:v>
+                  <c:v>245.5</c:v>
                 </c:pt>
                 <c:pt idx="35">
-                  <c:v>242.2</c:v>
+                  <c:v>247.7</c:v>
                 </c:pt>
                 <c:pt idx="36">
-                  <c:v>244.2</c:v>
+                  <c:v>250.0</c:v>
                 </c:pt>
               </c:numCache>
             </c:numRef>
@@ -1550,7 +1550,7 @@
           <a:p>
             <a:r>
               <a:rPr lang="en-US" dirty="0"/>
-              <a:t>Reference slide, not shown in the video timeline: keep for Q&amp;A. Earn autonomy with data, not claims. Shadow mode is the first deliverable: it produces the first real accuracy number and the human-override data without risking a customer. Say the limits out loud: the policy is ours, 17 cases show consistency not accuracy, the dispute rate is an assumption, V4 Flash has not been scored on this task, and the staff-time saving is only cash if Ryde avoids hiring or outsourcing.</a:t>
+              <a:t>The saved 3 October 2026 demonstration-corpus evaluation matched 17 of 18 labels and decided 14 of 18 without a human, before the 14 October switch to Flash advocates and Pro Judge. It is not a fresh measurement of the current build, real-world accuracy, or repeated-run consistency. The confidence value is model-reported. Our Python safeguards are selective, not all policy clauses. Kill switch and pre-model personal-data removal are before-go-live requirements, not shipped. Staff-time savings and workload are assumptions.</a:t>
             </a:r>
             <a:endParaRPr lang="en-US" dirty="0"/>
           </a:p>
@@ -1726,7 +1726,7 @@
           <a:p>
             <a:r>
               <a:rPr lang="en-US" dirty="0"/>
-              <a:t>Reference slide, not shown in the video timeline: keep for Q&amp;A. We propose embedding in Ryde's existing system because Ryde has in-house engineers and a customer-service stack already: the cost is its own staff time, and running it is only API tokens. A hosted service is the alternative if Ryde would rather not run it: faster to start and isolated, but it needs new infrastructure and an operator. Both use the same integration contract, so the choice can be changed later. Both beat doing nothing at our base assumptions; both depend on the dispute rate, which shadow mode measures. Hosted option figures: S$90k to build, about S$0.5k a month cloud, S$14 tokens and 0.1 engineer at S$1.2k.</a:t>
+              <a:t>Both options budget for Flash advocates + Pro Judge, not all-Flash billing. Embedded: S$120k setup staff time, S$175/month base token budget; 4 build, 2 shadow, 3 assist, autonomy from month 10. Hosted: S$90k setup; S$500 cloud + S$1,200 operator time + S$175 tokens = S$1,875/month at base volume; 3 build, 2 shadow, 3 assist, autonomy from month 9. Tokens scale with volume. Three-year spending is S$249,951 embedded or S$267,892.67 hosted, versus S$397,200 manual. Payback months 21 and 20. These are assumptions, not measured bills or savings.</a:t>
             </a:r>
             <a:endParaRPr lang="en-US" dirty="0"/>
           </a:p>
@@ -2078,7 +2078,7 @@
           <a:p>
             <a:r>
               <a:rPr lang="en-US" dirty="0"/>
-              <a:t>4:50-5:30. We propose embedding it in what Ryde already runs. A rider's report becomes a ticket in the existing CS tool; the ticket publishes a dispute event; our decision service, running in Ryde's own cluster, reads the evidence from Ryde's data services, calls the three Tencent Cloud ADP apps on DeepSeek V4 Flash, and returns a ruling or a withheld case to the same CS tool. Ryde's payments apply any refund and Ryde's CS agents review withheld cases in the tool they already use. No new infrastructure to buy: only the model calls leave Ryde. Rollout starts in shadow mode so customers see nothing while we measure agreement with human decisions. If Ryde would rather not host it, the same contract works as a hosted service: reference slide 13.</a:t>
+              <a:t>Deployment proposal, not a live Ryde integration. The current serving roles checked on 14 October are two advocates on DeepSeek V4 Flash and the Judge on V4 Pro. A ticket would trigger read-only evidence gathering and the decision service; Ryde would apply payments and review withheld cases in its own CS tool. The prototype records decisions, not money transfers.</a:t>
             </a:r>
             <a:endParaRPr lang="en-US" dirty="0"/>
           </a:p>
@@ -2166,7 +2166,7 @@
           <a:p>
             <a:r>
               <a:rPr lang="en-US" dirty="0"/>
-              <a:t>5:30-6:15. Because it is embedded, the cost is Ryde's own people and the model tokens. One-off: about S$120k of staff time, two engineers for four months plus product, QA and security review: an opportunity cost, not new cash. Running: only API tokens on DeepSeek V4 Flash, about S$14 a month at our assumed volume, because it runs on Ryde's existing infrastructure and support team. Rollout is nine months to limited autonomy. Staff cost, volume and tokens per case are our assumptions; the token rates are verified from Tencent Cloud's published prices. If Flash proves too weak, DeepSeek V4 Pro is still only about S$170 a month.</a:t>
+              <a:t>One-off provision: S$120k staff time, two engineers for four months plus PM, QA and security review. It is an opportunity cost, not new cash. Current roles: Flash advocates, Pro Judge. Budget S$175/month for model tokens at 1,333.33 cases, 50k input plus 3.5k output tokens per case and S$1.30/US$1. These are assumptions, not measured billing. Public reference scenarios are about S$46 all-Flash-GA-peak and S$172 all-unversioned-Pro, not proof of our billed SKU. Extra calls, larger token use and ADP plan fees can exceed the provision. Nine months to limited autonomy is a planning assumption.</a:t>
             </a:r>
             <a:endParaRPr lang="en-US" dirty="0"/>
           </a:p>
@@ -2254,7 +2254,7 @@
           <a:p>
             <a:r>
               <a:rPr lang="en-US" dirty="0"/>
-              <a:t>6:15-7:00. Start from the do-nothing line: at our base assumptions the in-scope disputes cost about S$400k over three years if handled by hand, growing with Ryde's volume. With our system, the same period costs about S$244k: S$120k of Ryde's own staff time to embed it, a few hundred dollars of tokens, and the manual work that remains. The lines cross around month 21, the payback, and the gap at month 36 is about S$153k, a return of about 127% on the staff time. The dispute rate is the swing factor and no platform publishes it: the closest reference is Uber, whose total support contacts, all topics, are about 1.3 per 100 trips, so 1% disputed is already generous. The break-even rate is about 0.4 to 0.5%. Shadow mode measures Ryde's real rate before anything is switched on. Note that agent time is salaried too: the saving is cash only to the extent Ryde avoids hiring or outsourcing as volume grows.</a:t>
+              <a:t>At the stated workload, staffing and rollout assumptions, do nothing costs S$397,200 over 36 months. Embedded costs S$249,951 including S$120k staff time and the revised S$175/month base token provision scaled with case volume. Saving S$147,249, 122.7% return on staff time, payback month 21. At 10% growth, 0.5% disputes pays back month 34; 1.5% month 17; 2% month 15. This is a scenario, not measured savings. Cash is saved only if hiring, overtime or outsourcing is avoided. Reproduce with python3 tools/deployment/cost_model.py.</a:t>
             </a:r>
             <a:endParaRPr lang="en-US" dirty="0"/>
           </a:p>
@@ -2342,7 +2342,7 @@
           <a:p>
             <a:r>
               <a:rPr lang="en-US" dirty="0"/>
-              <a:t>Reference slide, not shown in the video timeline: keep for Q&amp;A. The one-off is Ryde's own staff time: two engineers for four months at an assumed S$12,000 a month, plus product, QA and security review. It is an opportunity cost, not new cash. Running cost is API tokens only: the DeepSeek V4 Flash rates are verified from Tencent Cloud's ADP pricing, but the tokens per case (about 50k in, 3.5k out) are our estimate because the repo does not record real usage. Flash is unproven for this task: score it with the evaluation harness before go-live; V4 Pro is the fallback at about S$171 a month.</a:t>
+              <a:t>Current routing: Flash advocates + Pro Judge. The model mix is not all Flash. Role-level token usage and billed SKU are not measured. Reference prices checked on 16 October 2026 at https://www.tencentcloud.com/document/product/1300/78937, USD per million uncached tokens: Flash 0731 GA peak 0.44 input / 1.32 output; unversioned V4 Pro 1.74 / 3.48; Pro 0813 GA peak 1.32 / 3.96. These alternative rows are not invoice verification. Assume aggregate 50,000 input + 3,500 output tokens/case, 1,333.33 cases/month, FX S$1.30/US$1. S$175/month covers even the highest input/output reference rates combined at this allowance, without assuming an equal token split. It is a provision, not a spending cap. Extra usage and platform fees are excluded. Formula: cost_model.py.</a:t>
             </a:r>
             <a:endParaRPr lang="en-US" dirty="0"/>
           </a:p>
@@ -2430,7 +2430,7 @@
           <a:p>
             <a:r>
               <a:rPr lang="en-US" dirty="0"/>
-              <a:t>Reference slide, not shown in the video timeline: keep for Q&amp;A. No platform publishes its dispute rate; Grab does not, and the closest public reference is Uber's total support-contact rate of about 1.3 per 100 trips across all topics, derived from its engineering blog and 10-K. Disputes are a subset of contacts, so the 1% base is generous, and the table shows what happens at lower and higher rates and at different volume growth. Because the embedded option's running cost is only tokens, the break-even rate is low, about 0.4 to 0.5% of trips. Shadow mode replaces all of this with Ryde's measured rate.</a:t>
+              <a:t>Reference scenario recalculated with S$175/month token provision scaled with volume. Net saving and payback are from cost_model.py. At 10% growth the base saving is S$147k, payback month 21; at 0.5% disputes month 34; at 2% month 15. Break-even is 0.5065% flat or 0.4490% at 10% growth. No workload or savings result is measured. Existing Uber contact-rate comparison uses different years and all support topics, not Ryde disputes.</a:t>
             </a:r>
             <a:endParaRPr lang="en-US" dirty="0"/>
           </a:p>
@@ -4441,7 +4441,7 @@
                 <a:ea typeface="Calibri" pitchFamily="34" charset="-122"/>
                 <a:cs typeface="Calibri" pitchFamily="34" charset="-120"/>
               </a:rPr>
-              <a:t>17 labelled cases show consistency, not real-world accuracy</a:t>
+              <a:t>3 October 2026: 17 of 18 demo labels matched; not real-world accuracy</a:t>
             </a:r>
             <a:endParaRPr lang="en-US" sz="1300" dirty="0"/>
           </a:p>
@@ -4483,7 +4483,7 @@
                 <a:ea typeface="Calibri" pitchFamily="34" charset="-122"/>
                 <a:cs typeface="Calibri" pitchFamily="34" charset="-120"/>
               </a:rPr>
-              <a:t>DeepSeek V4 Flash is unproven here: score it first; V4 Pro is the fallback</a:t>
+              <a:t>Pre-switch result; Flash advocates + Pro Judge not re-scored</a:t>
             </a:r>
             <a:endParaRPr lang="en-US" sz="1300" dirty="0"/>
           </a:p>
@@ -5656,7 +5656,7 @@
                           <a:ea typeface="Calibri" pitchFamily="34" charset="-122"/>
                           <a:cs typeface="Calibri" pitchFamily="34" charset="-120"/>
                         </a:rPr>
-                        <a:t>About S$14 (tokens only)</a:t>
+                        <a:t>S$175 token budget</a:t>
                       </a:r>
                       <a:endParaRPr lang="en-US" sz="1200" dirty="0">
                         <a:latin typeface="Calibri" charset="0"/>
@@ -5721,7 +5721,7 @@
                           <a:ea typeface="Calibri" pitchFamily="34" charset="-122"/>
                           <a:cs typeface="Calibri" pitchFamily="34" charset="-120"/>
                         </a:rPr>
-                        <a:t>About S$1.7k (cloud, tokens, 0.1 engineer)</a:t>
+                        <a:t>About S$1.9k (cloud, tokens, 0.1 engineer)</a:t>
                       </a:r>
                       <a:endParaRPr lang="en-US" sz="1200" dirty="0">
                         <a:latin typeface="Calibri" charset="0"/>
@@ -5918,7 +5918,7 @@
                           <a:ea typeface="Calibri" pitchFamily="34" charset="-122"/>
                           <a:cs typeface="Calibri" pitchFamily="34" charset="-120"/>
                         </a:rPr>
-                        <a:t>S$244k</a:t>
+                        <a:t>S$250k</a:t>
                       </a:r>
                       <a:endParaRPr lang="en-US" sz="1200" dirty="0">
                         <a:latin typeface="Calibri" charset="0"/>
@@ -5983,7 +5983,7 @@
                           <a:ea typeface="Calibri" pitchFamily="34" charset="-122"/>
                           <a:cs typeface="Calibri" pitchFamily="34" charset="-120"/>
                         </a:rPr>
-                        <a:t>S$262k</a:t>
+                        <a:t>S$268k</a:t>
                       </a:r>
                       <a:endParaRPr lang="en-US" sz="1200" dirty="0">
                         <a:latin typeface="Calibri" charset="0"/>
@@ -6658,7 +6658,7 @@
                 <a:ea typeface="Calibri" pitchFamily="34" charset="-122"/>
                 <a:cs typeface="Calibri" pitchFamily="34" charset="-120"/>
               </a:rPr>
-              <a:t>ASSUMPTIONS: 1% of trips disputed, 40% in scope, S$7.50 each, 10% yearly growth, AI decides 60%, DeepSeek V4 Flash in both options. Spend is on in-scope disputes.</a:t>
+              <a:t>ASSUMPTIONS: 1% disputed, 40% in scope, S$7.50 each, 10% growth, 60% autonomous after rollout. Flash advocates + Pro Judge; S$175/month base token provision, not a bill.</a:t>
             </a:r>
             <a:endParaRPr lang="en-US" sz="1000" dirty="0"/>
           </a:p>
@@ -9196,7 +9196,7 @@
       </p:sp>
       <p:pic>
         <p:nvPicPr>
-          <p:cNvPr id="3" name="Image 0" descr="Architecture: the Ryde app creates a ticket in Ryde's existing CS tool; a dispute event goes to the decision service running in Ryde's own cluster (Evidence Pack, three agents, gates), which reads trips, GPS, fares and chat from Ryde's data services, calls Tencent Cloud ADP running DeepSeek V4 Flash, and returns a ruling or a withheld case to the CS tool; Ryde payments apply any refund and CS agents review withheld cases.">    </p:cNvPr>
+          <p:cNvPr id="3" name="Image 0" descr="Architecture: the Ryde app creates a ticket in Ryde's existing CS tool; a dispute event goes to the decision service running in Ryde's own cluster (Evidence Pack, three agents, gates), which reads trips, GPS, fares and chat from Ryde's data services, calls Tencent Cloud ADP: V4 Flash for the two advocates, V4 Pro for the Judge, and returns a ruling or a withheld case to the CS tool; Ryde payments apply any refund and CS agents review withheld cases.">    </p:cNvPr>
           <p:cNvPicPr>
             <a:picLocks noChangeAspect="1"/>
           </p:cNvPicPr>
@@ -9416,7 +9416,7 @@
                 <a:ea typeface="Calibri" pitchFamily="34" charset="-122"/>
                 <a:cs typeface="Calibri" pitchFamily="34" charset="-120"/>
               </a:rPr>
-              <a:t>About S$120k of staff time, then S$14 a month</a:t>
+              <a:t>About S$120k of staff time; budget S$175 a month</a:t>
             </a:r>
             <a:endParaRPr lang="en-US" sz="3000" dirty="0"/>
           </a:p>
@@ -9640,7 +9640,7 @@
                 <a:ea typeface="Calibri" pitchFamily="34" charset="-122"/>
                 <a:cs typeface="Calibri" pitchFamily="34" charset="-120"/>
               </a:rPr>
-              <a:t>S$14</a:t>
+              <a:t>S$175</a:t>
             </a:r>
             <a:endParaRPr lang="en-US" sz="3800" dirty="0"/>
           </a:p>
@@ -9679,7 +9679,7 @@
                 <a:ea typeface="Calibri" pitchFamily="34" charset="-122"/>
                 <a:cs typeface="Calibri" pitchFamily="34" charset="-120"/>
               </a:rPr>
-              <a:t>a month to run</a:t>
+              <a:t>monthly token budget</a:t>
             </a:r>
             <a:endParaRPr lang="en-US" sz="1600" dirty="0"/>
           </a:p>
@@ -9718,7 +9718,7 @@
                 <a:ea typeface="Calibri" pitchFamily="34" charset="-122"/>
                 <a:cs typeface="Calibri" pitchFamily="34" charset="-120"/>
               </a:rPr>
-              <a:t>API tokens only: DeepSeek V4 Flash, about S$0.01 a case. It runs on Ryde’s existing infrastructure and support team.</a:t>
+              <a:t>Flash advocates + Pro Judge. Not measured billing. The embedded option assumes existing infrastructure and support staff.</a:t>
             </a:r>
             <a:endParaRPr lang="en-US" sz="1300" dirty="0"/>
           </a:p>
@@ -9935,7 +9935,7 @@
                 <a:ea typeface="Calibri" pitchFamily="34" charset="-122"/>
                 <a:cs typeface="Calibri" pitchFamily="34" charset="-120"/>
               </a:rPr>
-              <a:t>Sized for about 1,300 in-scope cases a month. Even on the dearer DeepSeek V4 Pro, running cost is about S$170 a month.</a:t>
+              <a:t>At 1,333 cases/month and assumed tokens: reference scenarios S$46–172. Budget S$175; no per-role token split assumed.</a:t>
             </a:r>
             <a:endParaRPr lang="en-US" sz="1400" dirty="0"/>
           </a:p>
@@ -9974,7 +9974,7 @@
                 <a:ea typeface="Calibri" pitchFamily="34" charset="-122"/>
                 <a:cs typeface="Calibri" pitchFamily="34" charset="-120"/>
               </a:rPr>
-              <a:t>Token rates verified from Tencent Cloud ADP pages; tokens per case, staff cost and volume are ASSUMPTIONS. Breakdown on slide 8.</a:t>
+              <a:t>ASSUMPTIONS: token use, workload, FX and staff cost. Not measured spending. Extra calls/fees may exceed budget. See slide 8.</a:t>
             </a:r>
             <a:endParaRPr lang="en-US" sz="1000" dirty="0"/>
           </a:p>
@@ -10219,7 +10219,7 @@
                 <a:ea typeface="Calibri" pitchFamily="34" charset="-122"/>
                 <a:cs typeface="Calibri" pitchFamily="34" charset="-120"/>
               </a:rPr>
-              <a:t>S$244k</a:t>
+              <a:t>S$250k</a:t>
             </a:r>
             <a:endParaRPr lang="en-US" sz="3600" dirty="0"/>
           </a:p>
@@ -10297,7 +10297,7 @@
                 <a:ea typeface="Calibri" pitchFamily="34" charset="-122"/>
                 <a:cs typeface="Calibri" pitchFamily="34" charset="-120"/>
               </a:rPr>
-              <a:t>S$153k saved, </a:t>
+              <a:t>S$147k saved, 123% return on the staff time.</a:t>
             </a:r>
             <a:pPr indent="0" marL="0">
               <a:buNone/>
@@ -10311,7 +10311,7 @@
                 <a:ea typeface="Calibri" pitchFamily="34" charset="-122"/>
                 <a:cs typeface="Calibri" pitchFamily="34" charset="-120"/>
               </a:rPr>
-              <a:t>127% return on the staff time.</a:t>
+              <a:t/>
             </a:r>
             <a:endParaRPr lang="en-US" sz="1200" dirty="0"/>
           </a:p>
@@ -10564,7 +10564,7 @@
                           <a:ea typeface="Calibri" pitchFamily="34" charset="-122"/>
                           <a:cs typeface="Calibri" pitchFamily="34" charset="-120"/>
                         </a:rPr>
-                        <a:t>month 33</a:t>
+                        <a:t>month 34</a:t>
                       </a:r>
                       <a:endParaRPr lang="en-US" sz="1200" dirty="0">
                         <a:latin typeface="Calibri" charset="0"/>
@@ -10960,7 +10960,7 @@
                           <a:ea typeface="Calibri" pitchFamily="34" charset="-122"/>
                           <a:cs typeface="Calibri" pitchFamily="34" charset="-120"/>
                         </a:rPr>
-                        <a:t>month 14</a:t>
+                        <a:t>month 15</a:t>
                       </a:r>
                       <a:endParaRPr lang="en-US" sz="1200" dirty="0">
                         <a:latin typeface="Calibri" charset="0"/>
@@ -11046,7 +11046,7 @@
                 <a:ea typeface="Calibri" pitchFamily="34" charset="-122"/>
                 <a:cs typeface="Calibri" pitchFamily="34" charset="-120"/>
               </a:rPr>
-              <a:t>ASSUMPTIONS: 1% of trips disputed, 40% in scope, S$7.50 each, 10% yearly growth, AI decides 60%. Cost = Ryde staff time + API tokens. Uber reference: slide 9.</a:t>
+              <a:t>ASSUMPTIONS: 1% disputed, 40% in scope, S$7.50 each, 10% growth, 60% autonomous after rollout. Includes S$175/month token budget, scaled with volume. Not measured savings.</a:t>
             </a:r>
             <a:endParaRPr lang="en-US" sz="1000" dirty="0"/>
           </a:p>
@@ -12271,7 +12271,7 @@
                           <a:ea typeface="Calibri" pitchFamily="34" charset="-122"/>
                           <a:cs typeface="Calibri" pitchFamily="34" charset="-120"/>
                         </a:rPr>
-                        <a:t>DeepSeek V4 Flash (base)</a:t>
+                        <a:t>Current mix: token budget</a:t>
                       </a:r>
                       <a:endParaRPr lang="en-US" sz="1200" dirty="0">
                         <a:latin typeface="Calibri" charset="0"/>
@@ -12336,7 +12336,7 @@
                           <a:ea typeface="Calibri" pitchFamily="34" charset="-122"/>
                           <a:cs typeface="Calibri" pitchFamily="34" charset="-120"/>
                         </a:rPr>
-                        <a:t>11</a:t>
+                        <a:t>135</a:t>
                       </a:r>
                       <a:endParaRPr lang="en-US" sz="1200" dirty="0">
                         <a:latin typeface="Calibri" charset="0"/>
@@ -12401,7 +12401,7 @@
                           <a:ea typeface="Calibri" pitchFamily="34" charset="-122"/>
                           <a:cs typeface="Calibri" pitchFamily="34" charset="-120"/>
                         </a:rPr>
-                        <a:t>14</a:t>
+                        <a:t>175</a:t>
                       </a:r>
                       <a:endParaRPr lang="en-US" sz="1200" dirty="0">
                         <a:latin typeface="Calibri" charset="0"/>
@@ -12468,7 +12468,204 @@
                           <a:ea typeface="Calibri" pitchFamily="34" charset="-122"/>
                           <a:cs typeface="Calibri" pitchFamily="34" charset="-120"/>
                         </a:rPr>
-                        <a:t>DeepSeek V4 Pro</a:t>
+                        <a:t>Flash 0731 GA peak, all tokens</a:t>
+                      </a:r>
+                      <a:endParaRPr lang="en-US" sz="1200" dirty="0">
+                        <a:latin typeface="Calibri" charset="0"/>
+                        <a:ea typeface="Calibri" charset="0"/>
+                        <a:cs typeface="Calibri" charset="0"/>
+                      </a:endParaRPr>
+                    </a:p>
+                  </a:txBody>
+                  <a:tcPr marL="73152" marR="73152" marT="18288" marB="18288" anchor="ctr">
+                    <a:lnL w="6350" cap="flat" cmpd="sng" algn="ctr">
+                      <a:solidFill>
+                        <a:srgbClr val="E3E6EA"/>
+                      </a:solidFill>
+                      <a:prstDash val="solid"/>
+                      <a:round/>
+                      <a:headEnd type="none" w="med" len="med"/>
+                      <a:tailEnd type="none" w="med" len="med"/>
+                    </a:lnL>
+                    <a:lnR w="6350" cap="flat" cmpd="sng" algn="ctr">
+                      <a:solidFill>
+                        <a:srgbClr val="E3E6EA"/>
+                      </a:solidFill>
+                      <a:prstDash val="solid"/>
+                      <a:round/>
+                      <a:headEnd type="none" w="med" len="med"/>
+                      <a:tailEnd type="none" w="med" len="med"/>
+                    </a:lnR>
+                    <a:lnT w="6350" cap="flat" cmpd="sng" algn="ctr">
+                      <a:solidFill>
+                        <a:srgbClr val="E3E6EA"/>
+                      </a:solidFill>
+                      <a:prstDash val="solid"/>
+                      <a:round/>
+                      <a:headEnd type="none" w="med" len="med"/>
+                      <a:tailEnd type="none" w="med" len="med"/>
+                    </a:lnT>
+                    <a:lnB w="6350" cap="flat" cmpd="sng" algn="ctr">
+                      <a:solidFill>
+                        <a:srgbClr val="E3E6EA"/>
+                      </a:solidFill>
+                      <a:prstDash val="solid"/>
+                      <a:round/>
+                      <a:headEnd type="none" w="med" len="med"/>
+                      <a:tailEnd type="none" w="med" len="med"/>
+                    </a:lnB>
+                  </a:tcPr>
+                </a:tc>
+                <a:tc>
+                  <a:txBody>
+                    <a:bodyPr/>
+                    <a:lstStyle/>
+                    <a:p>
+                      <a:pPr indent="0" marL="0">
+                        <a:buNone/>
+                      </a:pPr>
+                      <a:r>
+                        <a:rPr lang="en-US" sz="1200" dirty="0">
+                          <a:solidFill>
+                            <a:srgbClr val="31373E"/>
+                          </a:solidFill>
+                          <a:latin typeface="Calibri" pitchFamily="34" charset="0"/>
+                          <a:ea typeface="Calibri" pitchFamily="34" charset="-122"/>
+                          <a:cs typeface="Calibri" pitchFamily="34" charset="-120"/>
+                        </a:rPr>
+                        <a:t>35</a:t>
+                      </a:r>
+                      <a:endParaRPr lang="en-US" sz="1200" dirty="0">
+                        <a:latin typeface="Calibri" charset="0"/>
+                        <a:ea typeface="Calibri" charset="0"/>
+                        <a:cs typeface="Calibri" charset="0"/>
+                      </a:endParaRPr>
+                    </a:p>
+                  </a:txBody>
+                  <a:tcPr marL="73152" marR="73152" marT="18288" marB="18288" anchor="ctr">
+                    <a:lnL w="6350" cap="flat" cmpd="sng" algn="ctr">
+                      <a:solidFill>
+                        <a:srgbClr val="E3E6EA"/>
+                      </a:solidFill>
+                      <a:prstDash val="solid"/>
+                      <a:round/>
+                      <a:headEnd type="none" w="med" len="med"/>
+                      <a:tailEnd type="none" w="med" len="med"/>
+                    </a:lnL>
+                    <a:lnR w="6350" cap="flat" cmpd="sng" algn="ctr">
+                      <a:solidFill>
+                        <a:srgbClr val="E3E6EA"/>
+                      </a:solidFill>
+                      <a:prstDash val="solid"/>
+                      <a:round/>
+                      <a:headEnd type="none" w="med" len="med"/>
+                      <a:tailEnd type="none" w="med" len="med"/>
+                    </a:lnR>
+                    <a:lnT w="6350" cap="flat" cmpd="sng" algn="ctr">
+                      <a:solidFill>
+                        <a:srgbClr val="E3E6EA"/>
+                      </a:solidFill>
+                      <a:prstDash val="solid"/>
+                      <a:round/>
+                      <a:headEnd type="none" w="med" len="med"/>
+                      <a:tailEnd type="none" w="med" len="med"/>
+                    </a:lnT>
+                    <a:lnB w="6350" cap="flat" cmpd="sng" algn="ctr">
+                      <a:solidFill>
+                        <a:srgbClr val="E3E6EA"/>
+                      </a:solidFill>
+                      <a:prstDash val="solid"/>
+                      <a:round/>
+                      <a:headEnd type="none" w="med" len="med"/>
+                      <a:tailEnd type="none" w="med" len="med"/>
+                    </a:lnB>
+                  </a:tcPr>
+                </a:tc>
+                <a:tc>
+                  <a:txBody>
+                    <a:bodyPr/>
+                    <a:lstStyle/>
+                    <a:p>
+                      <a:pPr indent="0" marL="0">
+                        <a:buNone/>
+                      </a:pPr>
+                      <a:r>
+                        <a:rPr lang="en-US" sz="1200" dirty="0">
+                          <a:solidFill>
+                            <a:srgbClr val="31373E"/>
+                          </a:solidFill>
+                          <a:latin typeface="Calibri" pitchFamily="34" charset="0"/>
+                          <a:ea typeface="Calibri" pitchFamily="34" charset="-122"/>
+                          <a:cs typeface="Calibri" pitchFamily="34" charset="-120"/>
+                        </a:rPr>
+                        <a:t>46</a:t>
+                      </a:r>
+                      <a:endParaRPr lang="en-US" sz="1200" dirty="0">
+                        <a:latin typeface="Calibri" charset="0"/>
+                        <a:ea typeface="Calibri" charset="0"/>
+                        <a:cs typeface="Calibri" charset="0"/>
+                      </a:endParaRPr>
+                    </a:p>
+                  </a:txBody>
+                  <a:tcPr marL="73152" marR="73152" marT="18288" marB="18288" anchor="ctr">
+                    <a:lnL w="6350" cap="flat" cmpd="sng" algn="ctr">
+                      <a:solidFill>
+                        <a:srgbClr val="E3E6EA"/>
+                      </a:solidFill>
+                      <a:prstDash val="solid"/>
+                      <a:round/>
+                      <a:headEnd type="none" w="med" len="med"/>
+                      <a:tailEnd type="none" w="med" len="med"/>
+                    </a:lnL>
+                    <a:lnR w="6350" cap="flat" cmpd="sng" algn="ctr">
+                      <a:solidFill>
+                        <a:srgbClr val="E3E6EA"/>
+                      </a:solidFill>
+                      <a:prstDash val="solid"/>
+                      <a:round/>
+                      <a:headEnd type="none" w="med" len="med"/>
+                      <a:tailEnd type="none" w="med" len="med"/>
+                    </a:lnR>
+                    <a:lnT w="6350" cap="flat" cmpd="sng" algn="ctr">
+                      <a:solidFill>
+                        <a:srgbClr val="E3E6EA"/>
+                      </a:solidFill>
+                      <a:prstDash val="solid"/>
+                      <a:round/>
+                      <a:headEnd type="none" w="med" len="med"/>
+                      <a:tailEnd type="none" w="med" len="med"/>
+                    </a:lnT>
+                    <a:lnB w="6350" cap="flat" cmpd="sng" algn="ctr">
+                      <a:solidFill>
+                        <a:srgbClr val="E3E6EA"/>
+                      </a:solidFill>
+                      <a:prstDash val="solid"/>
+                      <a:round/>
+                      <a:headEnd type="none" w="med" len="med"/>
+                      <a:tailEnd type="none" w="med" len="med"/>
+                    </a:lnB>
+                  </a:tcPr>
+                </a:tc>
+              </a:tr>
+              <a:tr h="310896">
+                <a:tc>
+                  <a:txBody>
+                    <a:bodyPr/>
+                    <a:lstStyle/>
+                    <a:p>
+                      <a:pPr indent="0" marL="0">
+                        <a:buNone/>
+                      </a:pPr>
+                      <a:r>
+                        <a:rPr lang="en-US" sz="1200" dirty="0">
+                          <a:solidFill>
+                            <a:srgbClr val="31373E"/>
+                          </a:solidFill>
+                          <a:latin typeface="Calibri" pitchFamily="34" charset="0"/>
+                          <a:ea typeface="Calibri" pitchFamily="34" charset="-122"/>
+                          <a:cs typeface="Calibri" pitchFamily="34" charset="-120"/>
+                        </a:rPr>
+                        <a:t>Unversioned V4 Pro, all tokens</a:t>
                       </a:r>
                       <a:endParaRPr lang="en-US" sz="1200" dirty="0">
                         <a:latin typeface="Calibri" charset="0"/>
@@ -12598,7 +12795,7 @@
                           <a:ea typeface="Calibri" pitchFamily="34" charset="-122"/>
                           <a:cs typeface="Calibri" pitchFamily="34" charset="-120"/>
                         </a:rPr>
-                        <a:t>171</a:t>
+                        <a:t>172</a:t>
                       </a:r>
                       <a:endParaRPr lang="en-US" sz="1200" dirty="0">
                         <a:latin typeface="Calibri" charset="0"/>
@@ -12665,7 +12862,7 @@
                           <a:ea typeface="Calibri" pitchFamily="34" charset="-122"/>
                           <a:cs typeface="Calibri" pitchFamily="34" charset="-120"/>
                         </a:rPr>
-                        <a:t>DeepSeek V3.1</a:t>
+                        <a:t>Actual mixed-model usage</a:t>
                       </a:r>
                       <a:endParaRPr lang="en-US" sz="1200" dirty="0">
                         <a:latin typeface="Calibri" charset="0"/>
@@ -12730,7 +12927,7 @@
                           <a:ea typeface="Calibri" pitchFamily="34" charset="-122"/>
                           <a:cs typeface="Calibri" pitchFamily="34" charset="-120"/>
                         </a:rPr>
-                        <a:t>342</a:t>
+                        <a:t>TBC</a:t>
                       </a:r>
                       <a:endParaRPr lang="en-US" sz="1200" dirty="0">
                         <a:latin typeface="Calibri" charset="0"/>
@@ -12795,204 +12992,7 @@
                           <a:ea typeface="Calibri" pitchFamily="34" charset="-122"/>
                           <a:cs typeface="Calibri" pitchFamily="34" charset="-120"/>
                         </a:rPr>
-                        <a:t>443</a:t>
-                      </a:r>
-                      <a:endParaRPr lang="en-US" sz="1200" dirty="0">
-                        <a:latin typeface="Calibri" charset="0"/>
-                        <a:ea typeface="Calibri" charset="0"/>
-                        <a:cs typeface="Calibri" charset="0"/>
-                      </a:endParaRPr>
-                    </a:p>
-                  </a:txBody>
-                  <a:tcPr marL="73152" marR="73152" marT="18288" marB="18288" anchor="ctr">
-                    <a:lnL w="6350" cap="flat" cmpd="sng" algn="ctr">
-                      <a:solidFill>
-                        <a:srgbClr val="E3E6EA"/>
-                      </a:solidFill>
-                      <a:prstDash val="solid"/>
-                      <a:round/>
-                      <a:headEnd type="none" w="med" len="med"/>
-                      <a:tailEnd type="none" w="med" len="med"/>
-                    </a:lnL>
-                    <a:lnR w="6350" cap="flat" cmpd="sng" algn="ctr">
-                      <a:solidFill>
-                        <a:srgbClr val="E3E6EA"/>
-                      </a:solidFill>
-                      <a:prstDash val="solid"/>
-                      <a:round/>
-                      <a:headEnd type="none" w="med" len="med"/>
-                      <a:tailEnd type="none" w="med" len="med"/>
-                    </a:lnR>
-                    <a:lnT w="6350" cap="flat" cmpd="sng" algn="ctr">
-                      <a:solidFill>
-                        <a:srgbClr val="E3E6EA"/>
-                      </a:solidFill>
-                      <a:prstDash val="solid"/>
-                      <a:round/>
-                      <a:headEnd type="none" w="med" len="med"/>
-                      <a:tailEnd type="none" w="med" len="med"/>
-                    </a:lnT>
-                    <a:lnB w="6350" cap="flat" cmpd="sng" algn="ctr">
-                      <a:solidFill>
-                        <a:srgbClr val="E3E6EA"/>
-                      </a:solidFill>
-                      <a:prstDash val="solid"/>
-                      <a:round/>
-                      <a:headEnd type="none" w="med" len="med"/>
-                      <a:tailEnd type="none" w="med" len="med"/>
-                    </a:lnB>
-                  </a:tcPr>
-                </a:tc>
-              </a:tr>
-              <a:tr h="310896">
-                <a:tc>
-                  <a:txBody>
-                    <a:bodyPr/>
-                    <a:lstStyle/>
-                    <a:p>
-                      <a:pPr indent="0" marL="0">
-                        <a:buNone/>
-                      </a:pPr>
-                      <a:r>
-                        <a:rPr lang="en-US" sz="1200" dirty="0">
-                          <a:solidFill>
-                            <a:srgbClr val="31373E"/>
-                          </a:solidFill>
-                          <a:latin typeface="Calibri" pitchFamily="34" charset="0"/>
-                          <a:ea typeface="Calibri" pitchFamily="34" charset="-122"/>
-                          <a:cs typeface="Calibri" pitchFamily="34" charset="-120"/>
-                        </a:rPr>
-                        <a:t>GPT-5.5</a:t>
-                      </a:r>
-                      <a:endParaRPr lang="en-US" sz="1200" dirty="0">
-                        <a:latin typeface="Calibri" charset="0"/>
-                        <a:ea typeface="Calibri" charset="0"/>
-                        <a:cs typeface="Calibri" charset="0"/>
-                      </a:endParaRPr>
-                    </a:p>
-                  </a:txBody>
-                  <a:tcPr marL="73152" marR="73152" marT="18288" marB="18288" anchor="ctr">
-                    <a:lnL w="6350" cap="flat" cmpd="sng" algn="ctr">
-                      <a:solidFill>
-                        <a:srgbClr val="E3E6EA"/>
-                      </a:solidFill>
-                      <a:prstDash val="solid"/>
-                      <a:round/>
-                      <a:headEnd type="none" w="med" len="med"/>
-                      <a:tailEnd type="none" w="med" len="med"/>
-                    </a:lnL>
-                    <a:lnR w="6350" cap="flat" cmpd="sng" algn="ctr">
-                      <a:solidFill>
-                        <a:srgbClr val="E3E6EA"/>
-                      </a:solidFill>
-                      <a:prstDash val="solid"/>
-                      <a:round/>
-                      <a:headEnd type="none" w="med" len="med"/>
-                      <a:tailEnd type="none" w="med" len="med"/>
-                    </a:lnR>
-                    <a:lnT w="6350" cap="flat" cmpd="sng" algn="ctr">
-                      <a:solidFill>
-                        <a:srgbClr val="E3E6EA"/>
-                      </a:solidFill>
-                      <a:prstDash val="solid"/>
-                      <a:round/>
-                      <a:headEnd type="none" w="med" len="med"/>
-                      <a:tailEnd type="none" w="med" len="med"/>
-                    </a:lnT>
-                    <a:lnB w="6350" cap="flat" cmpd="sng" algn="ctr">
-                      <a:solidFill>
-                        <a:srgbClr val="E3E6EA"/>
-                      </a:solidFill>
-                      <a:prstDash val="solid"/>
-                      <a:round/>
-                      <a:headEnd type="none" w="med" len="med"/>
-                      <a:tailEnd type="none" w="med" len="med"/>
-                    </a:lnB>
-                  </a:tcPr>
-                </a:tc>
-                <a:tc>
-                  <a:txBody>
-                    <a:bodyPr/>
-                    <a:lstStyle/>
-                    <a:p>
-                      <a:pPr indent="0" marL="0">
-                        <a:buNone/>
-                      </a:pPr>
-                      <a:r>
-                        <a:rPr lang="en-US" sz="1200" dirty="0">
-                          <a:solidFill>
-                            <a:srgbClr val="31373E"/>
-                          </a:solidFill>
-                          <a:latin typeface="Calibri" pitchFamily="34" charset="0"/>
-                          <a:ea typeface="Calibri" pitchFamily="34" charset="-122"/>
-                          <a:cs typeface="Calibri" pitchFamily="34" charset="-120"/>
-                        </a:rPr>
-                        <a:t>473</a:t>
-                      </a:r>
-                      <a:endParaRPr lang="en-US" sz="1200" dirty="0">
-                        <a:latin typeface="Calibri" charset="0"/>
-                        <a:ea typeface="Calibri" charset="0"/>
-                        <a:cs typeface="Calibri" charset="0"/>
-                      </a:endParaRPr>
-                    </a:p>
-                  </a:txBody>
-                  <a:tcPr marL="73152" marR="73152" marT="18288" marB="18288" anchor="ctr">
-                    <a:lnL w="6350" cap="flat" cmpd="sng" algn="ctr">
-                      <a:solidFill>
-                        <a:srgbClr val="E3E6EA"/>
-                      </a:solidFill>
-                      <a:prstDash val="solid"/>
-                      <a:round/>
-                      <a:headEnd type="none" w="med" len="med"/>
-                      <a:tailEnd type="none" w="med" len="med"/>
-                    </a:lnL>
-                    <a:lnR w="6350" cap="flat" cmpd="sng" algn="ctr">
-                      <a:solidFill>
-                        <a:srgbClr val="E3E6EA"/>
-                      </a:solidFill>
-                      <a:prstDash val="solid"/>
-                      <a:round/>
-                      <a:headEnd type="none" w="med" len="med"/>
-                      <a:tailEnd type="none" w="med" len="med"/>
-                    </a:lnR>
-                    <a:lnT w="6350" cap="flat" cmpd="sng" algn="ctr">
-                      <a:solidFill>
-                        <a:srgbClr val="E3E6EA"/>
-                      </a:solidFill>
-                      <a:prstDash val="solid"/>
-                      <a:round/>
-                      <a:headEnd type="none" w="med" len="med"/>
-                      <a:tailEnd type="none" w="med" len="med"/>
-                    </a:lnT>
-                    <a:lnB w="6350" cap="flat" cmpd="sng" algn="ctr">
-                      <a:solidFill>
-                        <a:srgbClr val="E3E6EA"/>
-                      </a:solidFill>
-                      <a:prstDash val="solid"/>
-                      <a:round/>
-                      <a:headEnd type="none" w="med" len="med"/>
-                      <a:tailEnd type="none" w="med" len="med"/>
-                    </a:lnB>
-                  </a:tcPr>
-                </a:tc>
-                <a:tc>
-                  <a:txBody>
-                    <a:bodyPr/>
-                    <a:lstStyle/>
-                    <a:p>
-                      <a:pPr indent="0" marL="0">
-                        <a:buNone/>
-                      </a:pPr>
-                      <a:r>
-                        <a:rPr lang="en-US" sz="1200" dirty="0">
-                          <a:solidFill>
-                            <a:srgbClr val="31373E"/>
-                          </a:solidFill>
-                          <a:latin typeface="Calibri" pitchFamily="34" charset="0"/>
-                          <a:ea typeface="Calibri" pitchFamily="34" charset="-122"/>
-                          <a:cs typeface="Calibri" pitchFamily="34" charset="-120"/>
-                        </a:rPr>
-                        <a:t>612</a:t>
+                        <a:t>TBC</a:t>
                       </a:r>
                       <a:endParaRPr lang="en-US" sz="1200" dirty="0">
                         <a:latin typeface="Calibri" charset="0"/>
@@ -13105,7 +13105,7 @@
                 <a:ea typeface="Calibri" pitchFamily="34" charset="-122"/>
                 <a:cs typeface="Calibri" pitchFamily="34" charset="-120"/>
               </a:rPr>
-              <a:t>About S$14 a month to run</a:t>
+              <a:t>S$175/month token budget</a:t>
             </a:r>
             <a:endParaRPr lang="en-US" sz="2000" dirty="0"/>
           </a:p>
@@ -13144,7 +13144,7 @@
                 <a:ea typeface="Calibri" pitchFamily="34" charset="-122"/>
                 <a:cs typeface="Calibri" pitchFamily="34" charset="-120"/>
               </a:rPr>
-              <a:t>API tokens only: about S$0.01 a case on DeepSeek V4 Flash, at 1,333 cases a month. Input caching could cut it further (not assumed).</a:t>
+              <a:t>Flash advocates + Pro Judge. Actual use is not measured. Reference rows are alternative price scenarios, not the billed SKU.</a:t>
             </a:r>
             <a:endParaRPr lang="en-US" sz="1200" dirty="0"/>
           </a:p>
@@ -13183,7 +13183,7 @@
                 <a:ea typeface="Calibri" pitchFamily="34" charset="-122"/>
                 <a:cs typeface="Calibri" pitchFamily="34" charset="-120"/>
               </a:rPr>
-              <a:t>Token rates per 1k tokens verified from Tencent Cloud ADP; tokens per case (50k in, 3.5k out) estimated. Excludes any ADP platform plan (Starter US$50 a month).</a:t>
+              <a:t>ASSUMED: 50k input + 3.5k output tokens/case; 1,333/month; S$1.30/US$1. Excludes ADP plan fees. Billed SKU needs confirmation. Formula: cost_model.py.</a:t>
             </a:r>
             <a:endParaRPr lang="en-US" sz="1000" dirty="0"/>
           </a:p>
@@ -13686,7 +13686,7 @@
                           <a:ea typeface="Calibri" pitchFamily="34" charset="-122"/>
                           <a:cs typeface="Calibri" pitchFamily="34" charset="-120"/>
                         </a:rPr>
-                        <a:t>−59k · none</a:t>
+                        <a:t>−61k · none</a:t>
                       </a:r>
                       <a:endParaRPr lang="en-US" sz="1200" dirty="0">
                         <a:latin typeface="Calibri" charset="0"/>
@@ -13751,7 +13751,7 @@
                           <a:ea typeface="Calibri" pitchFamily="34" charset="-122"/>
                           <a:cs typeface="Calibri" pitchFamily="34" charset="-120"/>
                         </a:rPr>
-                        <a:t>−52k · none</a:t>
+                        <a:t>−53k · none</a:t>
                       </a:r>
                       <a:endParaRPr lang="en-US" sz="1200" dirty="0">
                         <a:latin typeface="Calibri" charset="0"/>
@@ -13816,7 +13816,7 @@
                           <a:ea typeface="Calibri" pitchFamily="34" charset="-122"/>
                           <a:cs typeface="Calibri" pitchFamily="34" charset="-120"/>
                         </a:rPr>
-                        <a:t>−46k · none</a:t>
+                        <a:t>−48k · none</a:t>
                       </a:r>
                       <a:endParaRPr lang="en-US" sz="1200" dirty="0">
                         <a:latin typeface="Calibri" charset="0"/>
@@ -13948,7 +13948,7 @@
                           <a:ea typeface="Calibri" pitchFamily="34" charset="-122"/>
                           <a:cs typeface="Calibri" pitchFamily="34" charset="-120"/>
                         </a:rPr>
-                        <a:t>+1k · m36</a:t>
+                        <a:t>−2k · none</a:t>
                       </a:r>
                       <a:endParaRPr lang="en-US" sz="1200" dirty="0">
                         <a:latin typeface="Calibri" charset="0"/>
@@ -14013,7 +14013,7 @@
                           <a:ea typeface="Calibri" pitchFamily="34" charset="-122"/>
                           <a:cs typeface="Calibri" pitchFamily="34" charset="-120"/>
                         </a:rPr>
-                        <a:t>+17k · m33</a:t>
+                        <a:t>+14k · m34</a:t>
                       </a:r>
                       <a:endParaRPr lang="en-US" sz="1200" dirty="0">
                         <a:latin typeface="Calibri" charset="0"/>
@@ -14078,7 +14078,7 @@
                           <a:ea typeface="Calibri" pitchFamily="34" charset="-122"/>
                           <a:cs typeface="Calibri" pitchFamily="34" charset="-120"/>
                         </a:rPr>
-                        <a:t>+28k · m32</a:t>
+                        <a:t>+25k · m32</a:t>
                       </a:r>
                       <a:endParaRPr lang="en-US" sz="1200" dirty="0">
                         <a:latin typeface="Calibri" charset="0"/>
@@ -14210,7 +14210,7 @@
                           <a:ea typeface="Calibri" pitchFamily="34" charset="-122"/>
                           <a:cs typeface="Calibri" pitchFamily="34" charset="-120"/>
                         </a:rPr>
-                        <a:t>+122k · m22</a:t>
+                        <a:t>+117k · m22</a:t>
                       </a:r>
                       <a:endParaRPr lang="en-US" sz="1200" dirty="0">
                         <a:latin typeface="Calibri" charset="0"/>
@@ -14275,7 +14275,7 @@
                           <a:ea typeface="Calibri" pitchFamily="34" charset="-122"/>
                           <a:cs typeface="Calibri" pitchFamily="34" charset="-120"/>
                         </a:rPr>
-                        <a:t>+153k · m21</a:t>
+                        <a:t>+147k · m21</a:t>
                       </a:r>
                       <a:endParaRPr lang="en-US" sz="1200" dirty="0">
                         <a:latin typeface="Calibri" charset="0"/>
@@ -14340,7 +14340,7 @@
                           <a:ea typeface="Calibri" pitchFamily="34" charset="-122"/>
                           <a:cs typeface="Calibri" pitchFamily="34" charset="-120"/>
                         </a:rPr>
-                        <a:t>+176k · m20</a:t>
+                        <a:t>+170k · m21</a:t>
                       </a:r>
                       <a:endParaRPr lang="en-US" sz="1200" dirty="0">
                         <a:latin typeface="Calibri" charset="0"/>
@@ -14472,7 +14472,7 @@
                           <a:ea typeface="Calibri" pitchFamily="34" charset="-122"/>
                           <a:cs typeface="Calibri" pitchFamily="34" charset="-120"/>
                         </a:rPr>
-                        <a:t>+243k · m17</a:t>
+                        <a:t>+235k · m17</a:t>
                       </a:r>
                       <a:endParaRPr lang="en-US" sz="1200" dirty="0">
                         <a:latin typeface="Calibri" charset="0"/>
@@ -14537,7 +14537,7 @@
                           <a:ea typeface="Calibri" pitchFamily="34" charset="-122"/>
                           <a:cs typeface="Calibri" pitchFamily="34" charset="-120"/>
                         </a:rPr>
-                        <a:t>+290k · m17</a:t>
+                        <a:t>+281k · m17</a:t>
                       </a:r>
                       <a:endParaRPr lang="en-US" sz="1200" dirty="0">
                         <a:latin typeface="Calibri" charset="0"/>
@@ -14602,7 +14602,7 @@
                           <a:ea typeface="Calibri" pitchFamily="34" charset="-122"/>
                           <a:cs typeface="Calibri" pitchFamily="34" charset="-120"/>
                         </a:rPr>
-                        <a:t>+324k · m16</a:t>
+                        <a:t>+314k · m17</a:t>
                       </a:r>
                       <a:endParaRPr lang="en-US" sz="1200" dirty="0">
                         <a:latin typeface="Calibri" charset="0"/>
@@ -14734,7 +14734,7 @@
                           <a:ea typeface="Calibri" pitchFamily="34" charset="-122"/>
                           <a:cs typeface="Calibri" pitchFamily="34" charset="-120"/>
                         </a:rPr>
-                        <a:t>+364k · m15</a:t>
+                        <a:t>+354k · m15</a:t>
                       </a:r>
                       <a:endParaRPr lang="en-US" sz="1200" dirty="0">
                         <a:latin typeface="Calibri" charset="0"/>
@@ -14799,7 +14799,7 @@
                           <a:ea typeface="Calibri" pitchFamily="34" charset="-122"/>
                           <a:cs typeface="Calibri" pitchFamily="34" charset="-120"/>
                         </a:rPr>
-                        <a:t>+426k · m14</a:t>
+                        <a:t>+414k · m15</a:t>
                       </a:r>
                       <a:endParaRPr lang="en-US" sz="1200" dirty="0">
                         <a:latin typeface="Calibri" charset="0"/>
@@ -14864,7 +14864,7 @@
                           <a:ea typeface="Calibri" pitchFamily="34" charset="-122"/>
                           <a:cs typeface="Calibri" pitchFamily="34" charset="-120"/>
                         </a:rPr>
-                        <a:t>+472k · m14</a:t>
+                        <a:t>+459k · m14</a:t>
                       </a:r>
                       <a:endParaRPr lang="en-US" sz="1200" dirty="0">
                         <a:latin typeface="Calibri" charset="0"/>
@@ -14950,7 +14950,7 @@
                 <a:ea typeface="Calibri" pitchFamily="34" charset="-122"/>
                 <a:cs typeface="Calibri" pitchFamily="34" charset="-120"/>
               </a:rPr>
-              <a:t>Cells: 3-year net saving in S$k (staff time included) · payback month. Break-even rate over 3 years: about 0.50% of trips at flat volume, 0.44% at 10% growth.</a:t>
+              <a:t>Cells: 3-year net saving, S$k, and payback month. Includes revised token budget. Break-even: 0.51% of trips at flat volume, 0.45% at 10% growth.</a:t>
             </a:r>
             <a:endParaRPr lang="en-US" sz="1200" dirty="0"/>
           </a:p>

</xml_diff>